<commit_message>
Make the client-context slide a flow diagram rather than three text cards
</commit_message>
<xml_diff>
--- a/ahukannah_consultant_solutions.pptx
+++ b/ahukannah_consultant_solutions.pptx
@@ -10813,7 +10813,7 @@
                 <a:ea typeface="Calibri" pitchFamily="34" charset="-122"/>
                 <a:cs typeface="Calibri" pitchFamily="34" charset="-120"/>
               </a:rPr>
-              <a:t>A Madrid hub business where the e-commerce promise is the hardest part of the day.</a:t>
+              <a:t>One hub, two flows — and the e-commerce promise is the hardest part of the day.</a:t>
             </a:r>
             <a:endParaRPr lang="en-US" sz="1050" dirty="0"/>
           </a:p>
@@ -10922,14 +10922,489 @@
       </p:sp>
       <p:sp>
         <p:nvSpPr>
-          <p:cNvPr id="12" name="Shape 9"/>
+          <p:cNvPr id="12" name="Text 9"/>
           <p:cNvSpPr/>
           <p:nvPr/>
         </p:nvSpPr>
         <p:spPr>
           <a:xfrm>
             <a:off x="566928" y="2395728"/>
-            <a:ext cx="3502152" cy="2606040"/>
+            <a:ext cx="1828800" cy="237744"/>
+          </a:xfrm>
+          <a:prstGeom prst="rect">
+            <a:avLst/>
+          </a:prstGeom>
+          <a:noFill/>
+          <a:ln/>
+        </p:spPr>
+        <p:txBody>
+          <a:bodyPr wrap="square" lIns="0" tIns="0" rIns="0" bIns="0" rtlCol="0" anchor="ctr"/>
+          <a:lstStyle/>
+          <a:p>
+            <a:pPr indent="0" marL="0">
+              <a:buNone/>
+            </a:pPr>
+            <a:r>
+              <a:rPr lang="en-US" sz="850" b="1" spc="120" kern="0" dirty="0">
+                <a:solidFill>
+                  <a:srgbClr val="6B7C86"/>
+                </a:solidFill>
+                <a:latin typeface="Calibri" pitchFamily="34" charset="0"/>
+                <a:ea typeface="Calibri" pitchFamily="34" charset="-122"/>
+                <a:cs typeface="Calibri" pitchFamily="34" charset="-120"/>
+              </a:rPr>
+              <a:t>PALLET FREIGHT IN</a:t>
+            </a:r>
+            <a:endParaRPr lang="en-US" sz="850" dirty="0"/>
+          </a:p>
+        </p:txBody>
+      </p:sp>
+      <p:sp>
+        <p:nvSpPr>
+          <p:cNvPr id="13" name="Text 10"/>
+          <p:cNvSpPr/>
+          <p:nvPr/>
+        </p:nvSpPr>
+        <p:spPr>
+          <a:xfrm>
+            <a:off x="4754880" y="2395728"/>
+            <a:ext cx="2194560" cy="237744"/>
+          </a:xfrm>
+          <a:prstGeom prst="rect">
+            <a:avLst/>
+          </a:prstGeom>
+          <a:noFill/>
+          <a:ln/>
+        </p:spPr>
+        <p:txBody>
+          <a:bodyPr wrap="square" lIns="0" tIns="0" rIns="0" bIns="0" rtlCol="0" anchor="ctr"/>
+          <a:lstStyle/>
+          <a:p>
+            <a:pPr indent="0" marL="0">
+              <a:buNone/>
+            </a:pPr>
+            <a:r>
+              <a:rPr lang="en-US" sz="850" b="1" spc="120" kern="0" dirty="0">
+                <a:solidFill>
+                  <a:srgbClr val="6B7C86"/>
+                </a:solidFill>
+                <a:latin typeface="Calibri" pitchFamily="34" charset="0"/>
+                <a:ea typeface="Calibri" pitchFamily="34" charset="-122"/>
+                <a:cs typeface="Calibri" pitchFamily="34" charset="-120"/>
+              </a:rPr>
+              <a:t>LAST MILE OUT</a:t>
+            </a:r>
+            <a:endParaRPr lang="en-US" sz="850" dirty="0"/>
+          </a:p>
+        </p:txBody>
+      </p:sp>
+      <p:sp>
+        <p:nvSpPr>
+          <p:cNvPr id="14" name="Shape 11"/>
+          <p:cNvSpPr/>
+          <p:nvPr/>
+        </p:nvSpPr>
+        <p:spPr>
+          <a:xfrm>
+            <a:off x="566928" y="2724912"/>
+            <a:ext cx="1280160" cy="530352"/>
+          </a:xfrm>
+          <a:prstGeom prst="roundRect">
+            <a:avLst>
+              <a:gd name="adj" fmla="val 10345"/>
+            </a:avLst>
+          </a:prstGeom>
+          <a:solidFill>
+            <a:srgbClr val="FFFFFF"/>
+          </a:solidFill>
+          <a:ln w="12700">
+            <a:solidFill>
+              <a:srgbClr val="D6E2E8"/>
+            </a:solidFill>
+            <a:prstDash val="solid"/>
+          </a:ln>
+        </p:spPr>
+      </p:sp>
+      <p:sp>
+        <p:nvSpPr>
+          <p:cNvPr id="15" name="Text 12"/>
+          <p:cNvSpPr/>
+          <p:nvPr/>
+        </p:nvSpPr>
+        <p:spPr>
+          <a:xfrm>
+            <a:off x="621792" y="2724912"/>
+            <a:ext cx="1170432" cy="530352"/>
+          </a:xfrm>
+          <a:prstGeom prst="rect">
+            <a:avLst/>
+          </a:prstGeom>
+          <a:noFill/>
+          <a:ln/>
+        </p:spPr>
+        <p:txBody>
+          <a:bodyPr wrap="square" lIns="0" tIns="0" rIns="0" bIns="0" rtlCol="0" anchor="ctr"/>
+          <a:lstStyle/>
+          <a:p>
+            <a:pPr algn="ctr" indent="0" marL="0">
+              <a:buNone/>
+            </a:pPr>
+            <a:r>
+              <a:rPr lang="en-US" sz="1200" b="1" dirty="0">
+                <a:solidFill>
+                  <a:srgbClr val="16232B"/>
+                </a:solidFill>
+                <a:latin typeface="Calibri" pitchFamily="34" charset="0"/>
+                <a:ea typeface="Calibri" pitchFamily="34" charset="-122"/>
+                <a:cs typeface="Calibri" pitchFamily="34" charset="-120"/>
+              </a:rPr>
+              <a:t>Valencia</a:t>
+            </a:r>
+            <a:endParaRPr lang="en-US" sz="1200" dirty="0"/>
+          </a:p>
+        </p:txBody>
+      </p:sp>
+      <p:sp>
+        <p:nvSpPr>
+          <p:cNvPr id="16" name="Shape 13"/>
+          <p:cNvSpPr/>
+          <p:nvPr/>
+        </p:nvSpPr>
+        <p:spPr>
+          <a:xfrm>
+            <a:off x="566928" y="3456432"/>
+            <a:ext cx="1280160" cy="530352"/>
+          </a:xfrm>
+          <a:prstGeom prst="roundRect">
+            <a:avLst>
+              <a:gd name="adj" fmla="val 10345"/>
+            </a:avLst>
+          </a:prstGeom>
+          <a:solidFill>
+            <a:srgbClr val="FFFFFF"/>
+          </a:solidFill>
+          <a:ln w="12700">
+            <a:solidFill>
+              <a:srgbClr val="D6E2E8"/>
+            </a:solidFill>
+            <a:prstDash val="solid"/>
+          </a:ln>
+        </p:spPr>
+      </p:sp>
+      <p:sp>
+        <p:nvSpPr>
+          <p:cNvPr id="17" name="Text 14"/>
+          <p:cNvSpPr/>
+          <p:nvPr/>
+        </p:nvSpPr>
+        <p:spPr>
+          <a:xfrm>
+            <a:off x="621792" y="3456432"/>
+            <a:ext cx="1170432" cy="530352"/>
+          </a:xfrm>
+          <a:prstGeom prst="rect">
+            <a:avLst/>
+          </a:prstGeom>
+          <a:noFill/>
+          <a:ln/>
+        </p:spPr>
+        <p:txBody>
+          <a:bodyPr wrap="square" lIns="0" tIns="0" rIns="0" bIns="0" rtlCol="0" anchor="ctr"/>
+          <a:lstStyle/>
+          <a:p>
+            <a:pPr algn="ctr" indent="0" marL="0">
+              <a:buNone/>
+            </a:pPr>
+            <a:r>
+              <a:rPr lang="en-US" sz="1200" b="1" dirty="0">
+                <a:solidFill>
+                  <a:srgbClr val="16232B"/>
+                </a:solidFill>
+                <a:latin typeface="Calibri" pitchFamily="34" charset="0"/>
+                <a:ea typeface="Calibri" pitchFamily="34" charset="-122"/>
+                <a:cs typeface="Calibri" pitchFamily="34" charset="-120"/>
+              </a:rPr>
+              <a:t>Catalonia</a:t>
+            </a:r>
+            <a:endParaRPr lang="en-US" sz="1200" dirty="0"/>
+          </a:p>
+        </p:txBody>
+      </p:sp>
+      <p:sp>
+        <p:nvSpPr>
+          <p:cNvPr id="18" name="Shape 15"/>
+          <p:cNvSpPr/>
+          <p:nvPr/>
+        </p:nvSpPr>
+        <p:spPr>
+          <a:xfrm>
+            <a:off x="1920240" y="2862072"/>
+            <a:ext cx="384048" cy="274320"/>
+          </a:xfrm>
+          <a:prstGeom prst="rightArrow">
+            <a:avLst/>
+          </a:prstGeom>
+          <a:solidFill>
+            <a:srgbClr val="CFE0E7"/>
+          </a:solidFill>
+          <a:ln/>
+        </p:spPr>
+      </p:sp>
+      <p:sp>
+        <p:nvSpPr>
+          <p:cNvPr id="19" name="Shape 16"/>
+          <p:cNvSpPr/>
+          <p:nvPr/>
+        </p:nvSpPr>
+        <p:spPr>
+          <a:xfrm>
+            <a:off x="1920240" y="3593592"/>
+            <a:ext cx="384048" cy="274320"/>
+          </a:xfrm>
+          <a:prstGeom prst="rightArrow">
+            <a:avLst/>
+          </a:prstGeom>
+          <a:solidFill>
+            <a:srgbClr val="CFE0E7"/>
+          </a:solidFill>
+          <a:ln/>
+        </p:spPr>
+      </p:sp>
+      <p:sp>
+        <p:nvSpPr>
+          <p:cNvPr id="20" name="Shape 17"/>
+          <p:cNvSpPr/>
+          <p:nvPr/>
+        </p:nvSpPr>
+        <p:spPr>
+          <a:xfrm>
+            <a:off x="2395728" y="2670048"/>
+            <a:ext cx="1828800" cy="1371600"/>
+          </a:xfrm>
+          <a:prstGeom prst="roundRect">
+            <a:avLst>
+              <a:gd name="adj" fmla="val 4000"/>
+            </a:avLst>
+          </a:prstGeom>
+          <a:solidFill>
+            <a:srgbClr val="17384A"/>
+          </a:solidFill>
+          <a:ln w="12700">
+            <a:solidFill>
+              <a:srgbClr val="17384A"/>
+            </a:solidFill>
+            <a:prstDash val="solid"/>
+          </a:ln>
+        </p:spPr>
+      </p:sp>
+      <p:sp>
+        <p:nvSpPr>
+          <p:cNvPr id="21" name="Text 18"/>
+          <p:cNvSpPr/>
+          <p:nvPr/>
+        </p:nvSpPr>
+        <p:spPr>
+          <a:xfrm>
+            <a:off x="2450592" y="2670048"/>
+            <a:ext cx="1719072" cy="1371600"/>
+          </a:xfrm>
+          <a:prstGeom prst="rect">
+            <a:avLst/>
+          </a:prstGeom>
+          <a:noFill/>
+          <a:ln/>
+        </p:spPr>
+        <p:txBody>
+          <a:bodyPr wrap="square" lIns="0" tIns="0" rIns="0" bIns="0" rtlCol="0" anchor="ctr"/>
+          <a:lstStyle/>
+          <a:p>
+            <a:pPr algn="ctr" indent="0" marL="0">
+              <a:buNone/>
+            </a:pPr>
+            <a:r>
+              <a:rPr lang="en-US" sz="1200" b="1" dirty="0">
+                <a:solidFill>
+                  <a:srgbClr val="FFFFFF"/>
+                </a:solidFill>
+                <a:latin typeface="Calibri" pitchFamily="34" charset="0"/>
+                <a:ea typeface="Calibri" pitchFamily="34" charset="-122"/>
+                <a:cs typeface="Calibri" pitchFamily="34" charset="-120"/>
+              </a:rPr>
+              <a:t>COSLADA HUB</a:t>
+            </a:r>
+            <a:endParaRPr lang="en-US" sz="1200" dirty="0"/>
+          </a:p>
+          <a:p>
+            <a:pPr algn="ctr" indent="0" marL="0">
+              <a:buNone/>
+            </a:pPr>
+            <a:r>
+              <a:rPr lang="en-US" sz="900" dirty="0">
+                <a:solidFill>
+                  <a:srgbClr val="CFE0E7"/>
+                </a:solidFill>
+                <a:latin typeface="Calibri" pitchFamily="34" charset="0"/>
+                <a:ea typeface="Calibri" pitchFamily="34" charset="-122"/>
+                <a:cs typeface="Calibri" pitchFamily="34" charset="-120"/>
+              </a:rPr>
+              <a:t>Madrid</a:t>
+            </a:r>
+            <a:endParaRPr lang="en-US" sz="1200" dirty="0"/>
+          </a:p>
+        </p:txBody>
+      </p:sp>
+      <p:sp>
+        <p:nvSpPr>
+          <p:cNvPr id="22" name="Shape 19"/>
+          <p:cNvSpPr/>
+          <p:nvPr/>
+        </p:nvSpPr>
+        <p:spPr>
+          <a:xfrm>
+            <a:off x="4297680" y="3218688"/>
+            <a:ext cx="384048" cy="274320"/>
+          </a:xfrm>
+          <a:prstGeom prst="rightArrow">
+            <a:avLst/>
+          </a:prstGeom>
+          <a:solidFill>
+            <a:srgbClr val="CFE0E7"/>
+          </a:solidFill>
+          <a:ln/>
+        </p:spPr>
+      </p:sp>
+      <p:sp>
+        <p:nvSpPr>
+          <p:cNvPr id="23" name="Shape 20"/>
+          <p:cNvSpPr/>
+          <p:nvPr/>
+        </p:nvSpPr>
+        <p:spPr>
+          <a:xfrm>
+            <a:off x="4754880" y="2852928"/>
+            <a:ext cx="2194560" cy="1005840"/>
+          </a:xfrm>
+          <a:prstGeom prst="roundRect">
+            <a:avLst>
+              <a:gd name="adj" fmla="val 5455"/>
+            </a:avLst>
+          </a:prstGeom>
+          <a:solidFill>
+            <a:srgbClr val="D97706"/>
+          </a:solidFill>
+          <a:ln w="12700">
+            <a:solidFill>
+              <a:srgbClr val="D97706"/>
+            </a:solidFill>
+            <a:prstDash val="solid"/>
+          </a:ln>
+        </p:spPr>
+      </p:sp>
+      <p:sp>
+        <p:nvSpPr>
+          <p:cNvPr id="24" name="Text 21"/>
+          <p:cNvSpPr/>
+          <p:nvPr/>
+        </p:nvSpPr>
+        <p:spPr>
+          <a:xfrm>
+            <a:off x="4809744" y="2852928"/>
+            <a:ext cx="2084832" cy="1005840"/>
+          </a:xfrm>
+          <a:prstGeom prst="rect">
+            <a:avLst/>
+          </a:prstGeom>
+          <a:noFill/>
+          <a:ln/>
+        </p:spPr>
+        <p:txBody>
+          <a:bodyPr wrap="square" lIns="0" tIns="0" rIns="0" bIns="0" rtlCol="0" anchor="ctr"/>
+          <a:lstStyle/>
+          <a:p>
+            <a:pPr algn="ctr" indent="0" marL="0">
+              <a:buNone/>
+            </a:pPr>
+            <a:r>
+              <a:rPr lang="en-US" sz="1200" b="1" dirty="0">
+                <a:solidFill>
+                  <a:srgbClr val="0F1F2B"/>
+                </a:solidFill>
+                <a:latin typeface="Calibri" pitchFamily="34" charset="0"/>
+                <a:ea typeface="Calibri" pitchFamily="34" charset="-122"/>
+                <a:cs typeface="Calibri" pitchFamily="34" charset="-120"/>
+              </a:rPr>
+              <a:t>Madrid metro</a:t>
+            </a:r>
+            <a:endParaRPr lang="en-US" sz="1200" dirty="0"/>
+          </a:p>
+          <a:p>
+            <a:pPr algn="ctr" indent="0" marL="0">
+              <a:buNone/>
+            </a:pPr>
+            <a:r>
+              <a:rPr lang="en-US" sz="900" dirty="0">
+                <a:solidFill>
+                  <a:srgbClr val="7A3D00"/>
+                </a:solidFill>
+                <a:latin typeface="Calibri" pitchFamily="34" charset="0"/>
+                <a:ea typeface="Calibri" pitchFamily="34" charset="-122"/>
+                <a:cs typeface="Calibri" pitchFamily="34" charset="-120"/>
+              </a:rPr>
+              <a:t>B2C last-mile delivery</a:t>
+            </a:r>
+            <a:endParaRPr lang="en-US" sz="1200" dirty="0"/>
+          </a:p>
+        </p:txBody>
+      </p:sp>
+      <p:sp>
+        <p:nvSpPr>
+          <p:cNvPr id="25" name="Text 22"/>
+          <p:cNvSpPr/>
+          <p:nvPr/>
+        </p:nvSpPr>
+        <p:spPr>
+          <a:xfrm>
+            <a:off x="566928" y="4151376"/>
+            <a:ext cx="6400800" cy="256032"/>
+          </a:xfrm>
+          <a:prstGeom prst="rect">
+            <a:avLst/>
+          </a:prstGeom>
+          <a:noFill/>
+          <a:ln/>
+        </p:spPr>
+        <p:txBody>
+          <a:bodyPr wrap="square" lIns="0" tIns="0" rIns="0" bIns="0" rtlCol="0" anchor="ctr"/>
+          <a:lstStyle/>
+          <a:p>
+            <a:pPr algn="ctr" indent="0" marL="0">
+              <a:buNone/>
+            </a:pPr>
+            <a:r>
+              <a:rPr lang="en-US" sz="1000" i="1" dirty="0">
+                <a:solidFill>
+                  <a:srgbClr val="6B7C86"/>
+                </a:solidFill>
+                <a:latin typeface="Calibri" pitchFamily="34" charset="0"/>
+                <a:ea typeface="Calibri" pitchFamily="34" charset="-122"/>
+                <a:cs typeface="Calibri" pitchFamily="34" charset="-120"/>
+              </a:rPr>
+              <a:t>Own fleet, plus freelance drivers at peak</a:t>
+            </a:r>
+            <a:endParaRPr lang="en-US" sz="1000" dirty="0"/>
+          </a:p>
+        </p:txBody>
+      </p:sp>
+      <p:sp>
+        <p:nvSpPr>
+          <p:cNvPr id="26" name="Shape 23"/>
+          <p:cNvSpPr/>
+          <p:nvPr/>
+        </p:nvSpPr>
+        <p:spPr>
+          <a:xfrm>
+            <a:off x="7269480" y="2395728"/>
+            <a:ext cx="4352544" cy="2011680"/>
           </a:xfrm>
           <a:prstGeom prst="rect">
             <a:avLst/>
@@ -10954,14 +11429,14 @@
       </p:sp>
       <p:sp>
         <p:nvSpPr>
-          <p:cNvPr id="13" name="Text 10"/>
-          <p:cNvSpPr/>
-          <p:nvPr/>
-        </p:nvSpPr>
-        <p:spPr>
-          <a:xfrm>
-            <a:off x="768096" y="2578608"/>
-            <a:ext cx="3099816" cy="274320"/>
+          <p:cNvPr id="27" name="Text 24"/>
+          <p:cNvSpPr/>
+          <p:nvPr/>
+        </p:nvSpPr>
+        <p:spPr>
+          <a:xfrm>
+            <a:off x="7470648" y="2542032"/>
+            <a:ext cx="3941064" cy="310896"/>
           </a:xfrm>
           <a:prstGeom prst="rect">
             <a:avLst/>
@@ -10977,30 +11452,44 @@
               <a:buNone/>
             </a:pPr>
             <a:r>
-              <a:rPr lang="en-US" sz="950" b="1" spc="150" kern="0" dirty="0">
-                <a:solidFill>
-                  <a:srgbClr val="2E5C72"/>
-                </a:solidFill>
-                <a:latin typeface="Calibri" pitchFamily="34" charset="0"/>
-                <a:ea typeface="Calibri" pitchFamily="34" charset="-122"/>
-                <a:cs typeface="Calibri" pitchFamily="34" charset="-120"/>
-              </a:rPr>
-              <a:t>THE OPERATION</a:t>
-            </a:r>
-            <a:endParaRPr lang="en-US" sz="950" dirty="0"/>
-          </a:p>
-        </p:txBody>
-      </p:sp>
-      <p:sp>
-        <p:nvSpPr>
-          <p:cNvPr id="14" name="Text 11"/>
-          <p:cNvSpPr/>
-          <p:nvPr/>
-        </p:nvSpPr>
-        <p:spPr>
-          <a:xfrm>
-            <a:off x="768096" y="2852928"/>
-            <a:ext cx="3099816" cy="640080"/>
+              <a:rPr lang="en-US" sz="1100" dirty="0">
+                <a:solidFill>
+                  <a:srgbClr val="D97706"/>
+                </a:solidFill>
+                <a:latin typeface="Calibri" pitchFamily="34" charset="0"/>
+                <a:ea typeface="Calibri" pitchFamily="34" charset="-122"/>
+                <a:cs typeface="Calibri" pitchFamily="34" charset="-120"/>
+              </a:rPr>
+              <a:t>■ </a:t>
+            </a:r>
+            <a:pPr indent="0" marL="0">
+              <a:buNone/>
+            </a:pPr>
+            <a:r>
+              <a:rPr lang="en-US" sz="1300" b="1" dirty="0">
+                <a:solidFill>
+                  <a:srgbClr val="17384A"/>
+                </a:solidFill>
+                <a:latin typeface="Calibri" pitchFamily="34" charset="0"/>
+                <a:ea typeface="Calibri" pitchFamily="34" charset="-122"/>
+                <a:cs typeface="Calibri" pitchFamily="34" charset="-120"/>
+              </a:rPr>
+              <a:t>Who they serve, and the squeeze</a:t>
+            </a:r>
+            <a:endParaRPr lang="en-US" sz="1100" dirty="0"/>
+          </a:p>
+        </p:txBody>
+      </p:sp>
+      <p:sp>
+        <p:nvSpPr>
+          <p:cNvPr id="28" name="Text 25"/>
+          <p:cNvSpPr/>
+          <p:nvPr/>
+        </p:nvSpPr>
+        <p:spPr>
+          <a:xfrm>
+            <a:off x="7470648" y="2907792"/>
+            <a:ext cx="3941064" cy="1371600"/>
           </a:xfrm>
           <a:prstGeom prst="rect">
             <a:avLst/>
@@ -11012,50 +11501,15 @@
           <a:bodyPr wrap="square" lIns="0" tIns="0" rIns="0" bIns="0" rtlCol="0" anchor="t"/>
           <a:lstStyle/>
           <a:p>
-            <a:pPr indent="0" marL="0">
-              <a:buNone/>
-            </a:pPr>
-            <a:r>
-              <a:rPr lang="en-US" sz="1600" b="1" dirty="0">
-                <a:solidFill>
-                  <a:srgbClr val="17384A"/>
-                </a:solidFill>
-                <a:latin typeface="Georgia" pitchFamily="34" charset="0"/>
-                <a:ea typeface="Georgia" pitchFamily="34" charset="-122"/>
-                <a:cs typeface="Georgia" pitchFamily="34" charset="-120"/>
-              </a:rPr>
-              <a:t>One hub, two flows</a:t>
-            </a:r>
-            <a:endParaRPr lang="en-US" sz="1600" dirty="0"/>
-          </a:p>
-        </p:txBody>
-      </p:sp>
-      <p:sp>
-        <p:nvSpPr>
-          <p:cNvPr id="15" name="Text 12"/>
-          <p:cNvSpPr/>
-          <p:nvPr/>
-        </p:nvSpPr>
-        <p:spPr>
-          <a:xfrm>
-            <a:off x="768096" y="3474720"/>
-            <a:ext cx="3099816" cy="1417320"/>
-          </a:xfrm>
-          <a:prstGeom prst="rect">
-            <a:avLst/>
-          </a:prstGeom>
-          <a:noFill/>
-          <a:ln/>
-        </p:spPr>
-        <p:txBody>
-          <a:bodyPr wrap="square" lIns="0" tIns="0" rIns="0" bIns="0" rtlCol="0" anchor="t"/>
-          <a:lstStyle/>
-          <a:p>
-            <a:pPr indent="0" marL="0">
-              <a:buNone/>
-            </a:pPr>
-            <a:r>
-              <a:rPr lang="en-US" sz="1100" dirty="0">
+            <a:pPr marL="152400" indent="-152400">
+              <a:spcAft>
+                <a:spcPts val="500"/>
+              </a:spcAft>
+              <a:buSzPct val="100000"/>
+              <a:buChar char="•"/>
+            </a:pPr>
+            <a:r>
+              <a:rPr lang="en-US" sz="1050" dirty="0">
                 <a:solidFill>
                   <a:srgbClr val="16232B"/>
                 </a:solidFill>
@@ -11063,148 +11517,20 @@
                 <a:ea typeface="Calibri" pitchFamily="34" charset="-122"/>
                 <a:cs typeface="Calibri" pitchFamily="34" charset="-120"/>
               </a:rPr>
-              <a:t>Coslada, Madrid. Pallet freight in from Valencia and Catalonia; B2C last-mile across the Madrid metropolitan area. Own fleet, plus freelance drivers when volumes spike.</a:t>
-            </a:r>
-            <a:endParaRPr lang="en-US" sz="1100" dirty="0"/>
-          </a:p>
-        </p:txBody>
-      </p:sp>
-      <p:sp>
-        <p:nvSpPr>
-          <p:cNvPr id="16" name="Shape 13"/>
-          <p:cNvSpPr/>
-          <p:nvPr/>
-        </p:nvSpPr>
-        <p:spPr>
-          <a:xfrm>
-            <a:off x="4343400" y="2395728"/>
-            <a:ext cx="3502152" cy="2606040"/>
-          </a:xfrm>
-          <a:prstGeom prst="rect">
-            <a:avLst/>
-          </a:prstGeom>
-          <a:solidFill>
-            <a:srgbClr val="FFFFFF"/>
-          </a:solidFill>
-          <a:ln w="12700">
-            <a:solidFill>
-              <a:srgbClr val="D6E2E8"/>
-            </a:solidFill>
-            <a:prstDash val="solid"/>
-          </a:ln>
-          <a:effectLst>
-            <a:outerShdw sx="100000" sy="100000" kx="0" ky="0" algn="bl" rotWithShape="0" blurRad="88900" dist="38100" dir="8100000">
-              <a:srgbClr val="1C2440">
-                <a:alpha val="13000"/>
-              </a:srgbClr>
-            </a:outerShdw>
-          </a:effectLst>
-        </p:spPr>
-      </p:sp>
-      <p:sp>
-        <p:nvSpPr>
-          <p:cNvPr id="17" name="Text 14"/>
-          <p:cNvSpPr/>
-          <p:nvPr/>
-        </p:nvSpPr>
-        <p:spPr>
-          <a:xfrm>
-            <a:off x="4544568" y="2578608"/>
-            <a:ext cx="3099816" cy="274320"/>
-          </a:xfrm>
-          <a:prstGeom prst="rect">
-            <a:avLst/>
-          </a:prstGeom>
-          <a:noFill/>
-          <a:ln/>
-        </p:spPr>
-        <p:txBody>
-          <a:bodyPr wrap="square" lIns="0" tIns="0" rIns="0" bIns="0" rtlCol="0" anchor="ctr"/>
-          <a:lstStyle/>
-          <a:p>
-            <a:pPr indent="0" marL="0">
-              <a:buNone/>
-            </a:pPr>
-            <a:r>
-              <a:rPr lang="en-US" sz="950" b="1" spc="150" kern="0" dirty="0">
-                <a:solidFill>
-                  <a:srgbClr val="2E5C72"/>
-                </a:solidFill>
-                <a:latin typeface="Calibri" pitchFamily="34" charset="0"/>
-                <a:ea typeface="Calibri" pitchFamily="34" charset="-122"/>
-                <a:cs typeface="Calibri" pitchFamily="34" charset="-120"/>
-              </a:rPr>
-              <a:t>THE CUSTOMERS</a:t>
-            </a:r>
-            <a:endParaRPr lang="en-US" sz="950" dirty="0"/>
-          </a:p>
-        </p:txBody>
-      </p:sp>
-      <p:sp>
-        <p:nvSpPr>
-          <p:cNvPr id="18" name="Text 15"/>
-          <p:cNvSpPr/>
-          <p:nvPr/>
-        </p:nvSpPr>
-        <p:spPr>
-          <a:xfrm>
-            <a:off x="4544568" y="2852928"/>
-            <a:ext cx="3099816" cy="640080"/>
-          </a:xfrm>
-          <a:prstGeom prst="rect">
-            <a:avLst/>
-          </a:prstGeom>
-          <a:noFill/>
-          <a:ln/>
-        </p:spPr>
-        <p:txBody>
-          <a:bodyPr wrap="square" lIns="0" tIns="0" rIns="0" bIns="0" rtlCol="0" anchor="t"/>
-          <a:lstStyle/>
-          <a:p>
-            <a:pPr indent="0" marL="0">
-              <a:buNone/>
-            </a:pPr>
-            <a:r>
-              <a:rPr lang="en-US" sz="1600" b="1" dirty="0">
-                <a:solidFill>
-                  <a:srgbClr val="17384A"/>
-                </a:solidFill>
-                <a:latin typeface="Georgia" pitchFamily="34" charset="0"/>
-                <a:ea typeface="Georgia" pitchFamily="34" charset="-122"/>
-                <a:cs typeface="Georgia" pitchFamily="34" charset="-120"/>
-              </a:rPr>
-              <a:t>E-commerce sets the bar</a:t>
-            </a:r>
-            <a:endParaRPr lang="en-US" sz="1600" dirty="0"/>
-          </a:p>
-        </p:txBody>
-      </p:sp>
-      <p:sp>
-        <p:nvSpPr>
-          <p:cNvPr id="19" name="Text 16"/>
-          <p:cNvSpPr/>
-          <p:nvPr/>
-        </p:nvSpPr>
-        <p:spPr>
-          <a:xfrm>
-            <a:off x="4544568" y="3474720"/>
-            <a:ext cx="3099816" cy="1417320"/>
-          </a:xfrm>
-          <a:prstGeom prst="rect">
-            <a:avLst/>
-          </a:prstGeom>
-          <a:noFill/>
-          <a:ln/>
-        </p:spPr>
-        <p:txBody>
-          <a:bodyPr wrap="square" lIns="0" tIns="0" rIns="0" bIns="0" rtlCol="0" anchor="t"/>
-          <a:lstStyle/>
-          <a:p>
-            <a:pPr indent="0" marL="0">
-              <a:buNone/>
-            </a:pPr>
-            <a:r>
-              <a:rPr lang="en-US" sz="1100" dirty="0">
+              <a:t>E-commerce, B2B shippers and regular pallet contracts.</a:t>
+            </a:r>
+            <a:endParaRPr lang="en-US" sz="1050" dirty="0"/>
+          </a:p>
+          <a:p>
+            <a:pPr marL="152400" indent="-152400">
+              <a:spcAft>
+                <a:spcPts val="500"/>
+              </a:spcAft>
+              <a:buSzPct val="100000"/>
+              <a:buChar char="•"/>
+            </a:pPr>
+            <a:r>
+              <a:rPr lang="en-US" sz="1050" dirty="0">
                 <a:solidFill>
                   <a:srgbClr val="16232B"/>
                 </a:solidFill>
@@ -11212,165 +11538,63 @@
                 <a:ea typeface="Calibri" pitchFamily="34" charset="-122"/>
                 <a:cs typeface="Calibri" pitchFamily="34" charset="-120"/>
               </a:rPr>
-              <a:t>E-commerce companies, B2B shippers, and businesses on regular parcel or pallet contracts. The e-commerce end expects fast delivery and increasingly precise arrival information.</a:t>
-            </a:r>
-            <a:endParaRPr lang="en-US" sz="1100" dirty="0"/>
-          </a:p>
-        </p:txBody>
-      </p:sp>
-      <p:sp>
-        <p:nvSpPr>
-          <p:cNvPr id="20" name="Shape 17"/>
-          <p:cNvSpPr/>
-          <p:nvPr/>
-        </p:nvSpPr>
-        <p:spPr>
-          <a:xfrm>
-            <a:off x="8119872" y="2395728"/>
-            <a:ext cx="3502152" cy="2606040"/>
-          </a:xfrm>
-          <a:prstGeom prst="rect">
-            <a:avLst/>
-          </a:prstGeom>
-          <a:solidFill>
-            <a:srgbClr val="17384A"/>
-          </a:solidFill>
-          <a:ln/>
-          <a:effectLst>
-            <a:outerShdw sx="100000" sy="100000" kx="0" ky="0" algn="bl" rotWithShape="0" blurRad="88900" dist="38100" dir="8100000">
-              <a:srgbClr val="1C2440">
-                <a:alpha val="13000"/>
-              </a:srgbClr>
-            </a:outerShdw>
-          </a:effectLst>
-        </p:spPr>
-      </p:sp>
-      <p:sp>
-        <p:nvSpPr>
-          <p:cNvPr id="21" name="Text 18"/>
-          <p:cNvSpPr/>
-          <p:nvPr/>
-        </p:nvSpPr>
-        <p:spPr>
-          <a:xfrm>
-            <a:off x="8321040" y="2578608"/>
-            <a:ext cx="3099816" cy="274320"/>
-          </a:xfrm>
-          <a:prstGeom prst="rect">
-            <a:avLst/>
-          </a:prstGeom>
-          <a:noFill/>
-          <a:ln/>
-        </p:spPr>
-        <p:txBody>
-          <a:bodyPr wrap="square" lIns="0" tIns="0" rIns="0" bIns="0" rtlCol="0" anchor="ctr"/>
-          <a:lstStyle/>
-          <a:p>
-            <a:pPr indent="0" marL="0">
-              <a:buNone/>
-            </a:pPr>
-            <a:r>
-              <a:rPr lang="en-US" sz="950" b="1" spc="150" kern="0" dirty="0">
-                <a:solidFill>
-                  <a:srgbClr val="D97706"/>
-                </a:solidFill>
-                <a:latin typeface="Calibri" pitchFamily="34" charset="0"/>
-                <a:ea typeface="Calibri" pitchFamily="34" charset="-122"/>
-                <a:cs typeface="Calibri" pitchFamily="34" charset="-120"/>
-              </a:rPr>
-              <a:t>THE PRESSURE</a:t>
-            </a:r>
-            <a:endParaRPr lang="en-US" sz="950" dirty="0"/>
-          </a:p>
-        </p:txBody>
-      </p:sp>
-      <p:sp>
-        <p:nvSpPr>
-          <p:cNvPr id="22" name="Text 19"/>
-          <p:cNvSpPr/>
-          <p:nvPr/>
-        </p:nvSpPr>
-        <p:spPr>
-          <a:xfrm>
-            <a:off x="8321040" y="2852928"/>
-            <a:ext cx="3099816" cy="640080"/>
-          </a:xfrm>
-          <a:prstGeom prst="rect">
-            <a:avLst/>
-          </a:prstGeom>
-          <a:noFill/>
-          <a:ln/>
-        </p:spPr>
-        <p:txBody>
-          <a:bodyPr wrap="square" lIns="0" tIns="0" rIns="0" bIns="0" rtlCol="0" anchor="t"/>
-          <a:lstStyle/>
-          <a:p>
-            <a:pPr indent="0" marL="0">
-              <a:buNone/>
-            </a:pPr>
-            <a:r>
-              <a:rPr lang="en-US" sz="1600" b="1" dirty="0">
-                <a:solidFill>
-                  <a:srgbClr val="FFFFFF"/>
-                </a:solidFill>
-                <a:latin typeface="Georgia" pitchFamily="34" charset="0"/>
-                <a:ea typeface="Georgia" pitchFamily="34" charset="-122"/>
-                <a:cs typeface="Georgia" pitchFamily="34" charset="-120"/>
-              </a:rPr>
-              <a:t>More reliable, not more vans</a:t>
-            </a:r>
-            <a:endParaRPr lang="en-US" sz="1600" dirty="0"/>
-          </a:p>
-        </p:txBody>
-      </p:sp>
-      <p:sp>
-        <p:nvSpPr>
-          <p:cNvPr id="23" name="Text 20"/>
-          <p:cNvSpPr/>
-          <p:nvPr/>
-        </p:nvSpPr>
-        <p:spPr>
-          <a:xfrm>
-            <a:off x="8321040" y="3474720"/>
-            <a:ext cx="3099816" cy="1417320"/>
-          </a:xfrm>
-          <a:prstGeom prst="rect">
-            <a:avLst/>
-          </a:prstGeom>
-          <a:noFill/>
-          <a:ln/>
-        </p:spPr>
-        <p:txBody>
-          <a:bodyPr wrap="square" lIns="0" tIns="0" rIns="0" bIns="0" rtlCol="0" anchor="t"/>
-          <a:lstStyle/>
-          <a:p>
-            <a:pPr indent="0" marL="0">
-              <a:buNone/>
-            </a:pPr>
-            <a:r>
-              <a:rPr lang="en-US" sz="1100" dirty="0">
-                <a:solidFill>
-                  <a:srgbClr val="FFFFFF"/>
-                </a:solidFill>
-                <a:latin typeface="Calibri" pitchFamily="34" charset="0"/>
-                <a:ea typeface="Calibri" pitchFamily="34" charset="-122"/>
-                <a:cs typeface="Calibri" pitchFamily="34" charset="-120"/>
-              </a:rPr>
-              <a:t>Volumes spike at Black Friday and Christmas. Margins are tight. Management wants reliability out of the resources already in place — not a bigger fleet and not more people.</a:t>
-            </a:r>
-            <a:endParaRPr lang="en-US" sz="1100" dirty="0"/>
-          </a:p>
-        </p:txBody>
-      </p:sp>
-      <p:sp>
-        <p:nvSpPr>
-          <p:cNvPr id="24" name="Shape 21"/>
-          <p:cNvSpPr/>
-          <p:nvPr/>
-        </p:nvSpPr>
-        <p:spPr>
-          <a:xfrm>
-            <a:off x="566928" y="5385816"/>
+              <a:t>E-commerce sets the bar: fast delivery, and precise arrival information.</a:t>
+            </a:r>
+            <a:endParaRPr lang="en-US" sz="1050" dirty="0"/>
+          </a:p>
+          <a:p>
+            <a:pPr marL="152400" indent="-152400">
+              <a:spcAft>
+                <a:spcPts val="500"/>
+              </a:spcAft>
+              <a:buSzPct val="100000"/>
+              <a:buChar char="•"/>
+            </a:pPr>
+            <a:r>
+              <a:rPr lang="en-US" sz="1050" dirty="0">
+                <a:solidFill>
+                  <a:srgbClr val="16232B"/>
+                </a:solidFill>
+                <a:latin typeface="Calibri" pitchFamily="34" charset="0"/>
+                <a:ea typeface="Calibri" pitchFamily="34" charset="-122"/>
+                <a:cs typeface="Calibri" pitchFamily="34" charset="-120"/>
+              </a:rPr>
+              <a:t>Volumes spike hard at Black Friday and Christmas.</a:t>
+            </a:r>
+            <a:endParaRPr lang="en-US" sz="1050" dirty="0"/>
+          </a:p>
+          <a:p>
+            <a:pPr marL="152400" indent="-152400">
+              <a:spcAft>
+                <a:spcPts val="500"/>
+              </a:spcAft>
+              <a:buSzPct val="100000"/>
+              <a:buChar char="•"/>
+            </a:pPr>
+            <a:r>
+              <a:rPr lang="en-US" sz="1050" dirty="0">
+                <a:solidFill>
+                  <a:srgbClr val="16232B"/>
+                </a:solidFill>
+                <a:latin typeface="Calibri" pitchFamily="34" charset="0"/>
+                <a:ea typeface="Calibri" pitchFamily="34" charset="-122"/>
+                <a:cs typeface="Calibri" pitchFamily="34" charset="-120"/>
+              </a:rPr>
+              <a:t>Margins are tight — more reliability from the same vans and people.</a:t>
+            </a:r>
+            <a:endParaRPr lang="en-US" sz="1050" dirty="0"/>
+          </a:p>
+        </p:txBody>
+      </p:sp>
+      <p:sp>
+        <p:nvSpPr>
+          <p:cNvPr id="29" name="Shape 26"/>
+          <p:cNvSpPr/>
+          <p:nvPr/>
+        </p:nvSpPr>
+        <p:spPr>
+          <a:xfrm>
+            <a:off x="566928" y="5065776"/>
             <a:ext cx="11055096" cy="786384"/>
           </a:xfrm>
           <a:prstGeom prst="rect">
@@ -11384,13 +11608,13 @@
       </p:sp>
       <p:sp>
         <p:nvSpPr>
-          <p:cNvPr id="25" name="Shape 22"/>
-          <p:cNvSpPr/>
-          <p:nvPr/>
-        </p:nvSpPr>
-        <p:spPr>
-          <a:xfrm>
-            <a:off x="566928" y="5385816"/>
+          <p:cNvPr id="30" name="Shape 27"/>
+          <p:cNvSpPr/>
+          <p:nvPr/>
+        </p:nvSpPr>
+        <p:spPr>
+          <a:xfrm>
+            <a:off x="566928" y="5065776"/>
             <a:ext cx="82296" cy="786384"/>
           </a:xfrm>
           <a:prstGeom prst="rect">
@@ -11404,13 +11628,13 @@
       </p:sp>
       <p:sp>
         <p:nvSpPr>
-          <p:cNvPr id="26" name="Text 23"/>
-          <p:cNvSpPr/>
-          <p:nvPr/>
-        </p:nvSpPr>
-        <p:spPr>
-          <a:xfrm>
-            <a:off x="822960" y="5385816"/>
+          <p:cNvPr id="31" name="Text 28"/>
+          <p:cNvSpPr/>
+          <p:nvPr/>
+        </p:nvSpPr>
+        <p:spPr>
+          <a:xfrm>
+            <a:off x="822960" y="5065776"/>
             <a:ext cx="10597896" cy="786384"/>
           </a:xfrm>
           <a:prstGeom prst="rect">

</xml_diff>

<commit_message>
Replace the paraphrased goal line with the client's verbatim words
</commit_message>
<xml_diff>
--- a/ahukannah_consultant_solutions.pptx
+++ b/ahukannah_consultant_solutions.pptx
@@ -16214,7 +16214,7 @@
         <p:spPr>
           <a:xfrm>
             <a:off x="566928" y="5001768"/>
-            <a:ext cx="11055096" cy="713232"/>
+            <a:ext cx="11055096" cy="786384"/>
           </a:xfrm>
           <a:prstGeom prst="rect">
             <a:avLst/>
@@ -16234,7 +16234,7 @@
         <p:spPr>
           <a:xfrm>
             <a:off x="566928" y="5001768"/>
-            <a:ext cx="82296" cy="713232"/>
+            <a:ext cx="82296" cy="786384"/>
           </a:xfrm>
           <a:prstGeom prst="rect">
             <a:avLst/>
@@ -16254,7 +16254,7 @@
         <p:spPr>
           <a:xfrm>
             <a:off x="822960" y="5001768"/>
-            <a:ext cx="10597896" cy="713232"/>
+            <a:ext cx="10597896" cy="786384"/>
           </a:xfrm>
           <a:prstGeom prst="rect">
             <a:avLst/>
@@ -16270,7 +16270,7 @@
               <a:buNone/>
             </a:pPr>
             <a:r>
-              <a:rPr lang="en-US" sz="1250" b="1" dirty="0">
+              <a:rPr lang="en-US" sz="1100" b="1" spc="100" kern="0" dirty="0">
                 <a:solidFill>
                   <a:srgbClr val="D97706"/>
                 </a:solidFill>
@@ -16278,13 +16278,13 @@
                 <a:ea typeface="Calibri" pitchFamily="34" charset="-122"/>
                 <a:cs typeface="Calibri" pitchFamily="34" charset="-120"/>
               </a:rPr>
-              <a:t>So the goal is your goal:   </a:t>
+              <a:t>IN YOUR WORDS   </a:t>
             </a:r>
             <a:pPr indent="0" marL="0">
               <a:buNone/>
             </a:pPr>
             <a:r>
-              <a:rPr lang="en-US" sz="1250" dirty="0">
+              <a:rPr lang="en-US" sz="1250" i="1" dirty="0">
                 <a:solidFill>
                   <a:srgbClr val="16232B"/>
                 </a:solidFill>
@@ -16292,7 +16292,7 @@
                 <a:ea typeface="Calibri" pitchFamily="34" charset="-122"/>
                 <a:cs typeface="Calibri" pitchFamily="34" charset="-120"/>
               </a:rPr>
-              <a:t>more reliable deliveries without adding vehicles or people every time volume grows.</a:t>
+              <a:t>“The main priority is to make deliveries more reliable without simply adding more vehicles or more people every time volumes grow.”</a:t>
             </a:r>
             <a:endParaRPr lang="en-US" sz="1250" dirty="0"/>
           </a:p>

</xml_diff>

<commit_message>
Relabel the kicker from discovery to proposed approach where the deck starts proposing
</commit_message>
<xml_diff>
--- a/ahukannah_consultant_solutions.pptx
+++ b/ahukannah_consultant_solutions.pptx
@@ -3087,7 +3087,7 @@
                 <a:ea typeface="Calibri" pitchFamily="34" charset="-122"/>
                 <a:cs typeface="Calibri" pitchFamily="34" charset="-120"/>
               </a:rPr>
-              <a:t>SILVERTRUST   ·   IBERIANEX LOGISTICS S.A.   ·   DISCOVERY FINDINGS</a:t>
+              <a:t>SILVERTRUST   ·   IBERIANEX LOGISTICS S.A.   ·   PROPOSED APPROACH</a:t>
             </a:r>
             <a:endParaRPr lang="en-US" sz="1050" dirty="0"/>
           </a:p>
@@ -4172,7 +4172,7 @@
                 <a:ea typeface="Calibri" pitchFamily="34" charset="-122"/>
                 <a:cs typeface="Calibri" pitchFamily="34" charset="-120"/>
               </a:rPr>
-              <a:t>SILVERTRUST   ·   IBERIANEX LOGISTICS S.A.   ·   DISCOVERY FINDINGS</a:t>
+              <a:t>SILVERTRUST   ·   IBERIANEX LOGISTICS S.A.   ·   PROPOSED APPROACH</a:t>
             </a:r>
             <a:endParaRPr lang="en-US" sz="1050" dirty="0"/>
           </a:p>
@@ -5107,7 +5107,7 @@
                 <a:ea typeface="Calibri" pitchFamily="34" charset="-122"/>
                 <a:cs typeface="Calibri" pitchFamily="34" charset="-120"/>
               </a:rPr>
-              <a:t>SILVERTRUST   ·   IBERIANEX LOGISTICS S.A.   ·   DISCOVERY FINDINGS</a:t>
+              <a:t>SILVERTRUST   ·   IBERIANEX LOGISTICS S.A.   ·   PROPOSED APPROACH</a:t>
             </a:r>
             <a:endParaRPr lang="en-US" sz="1050" dirty="0"/>
           </a:p>
@@ -5963,7 +5963,7 @@
                 <a:ea typeface="Calibri" pitchFamily="34" charset="-122"/>
                 <a:cs typeface="Calibri" pitchFamily="34" charset="-120"/>
               </a:rPr>
-              <a:t>SILVERTRUST   ·   IBERIANEX LOGISTICS S.A.   ·   DISCOVERY FINDINGS</a:t>
+              <a:t>SILVERTRUST   ·   IBERIANEX LOGISTICS S.A.   ·   PROPOSED APPROACH</a:t>
             </a:r>
             <a:endParaRPr lang="en-US" sz="1050" dirty="0"/>
           </a:p>
@@ -7629,7 +7629,7 @@
                 <a:ea typeface="Calibri" pitchFamily="34" charset="-122"/>
                 <a:cs typeface="Calibri" pitchFamily="34" charset="-120"/>
               </a:rPr>
-              <a:t>SILVERTRUST   ·   IBERIANEX LOGISTICS S.A.   ·   DISCOVERY FINDINGS</a:t>
+              <a:t>SILVERTRUST   ·   IBERIANEX LOGISTICS S.A.   ·   PROPOSED APPROACH</a:t>
             </a:r>
             <a:endParaRPr lang="en-US" sz="1050" dirty="0"/>
           </a:p>
@@ -8857,7 +8857,7 @@
                 <a:ea typeface="Calibri" pitchFamily="34" charset="-122"/>
                 <a:cs typeface="Calibri" pitchFamily="34" charset="-120"/>
               </a:rPr>
-              <a:t>SILVERTRUST   ·   IBERIANEX LOGISTICS S.A.   ·   DISCOVERY FINDINGS</a:t>
+              <a:t>SILVERTRUST   ·   IBERIANEX LOGISTICS S.A.   ·   PROPOSED APPROACH</a:t>
             </a:r>
             <a:endParaRPr lang="en-US" sz="1050" dirty="0"/>
           </a:p>
@@ -10072,7 +10072,7 @@
                 <a:ea typeface="Calibri" pitchFamily="34" charset="-122"/>
                 <a:cs typeface="Calibri" pitchFamily="34" charset="-120"/>
               </a:rPr>
-              <a:t>SILVERTRUST   ·   IBERIANEX LOGISTICS S.A.   ·   DISCOVERY FINDINGS</a:t>
+              <a:t>SILVERTRUST   ·   IBERIANEX LOGISTICS S.A.   ·   PROPOSED APPROACH</a:t>
             </a:r>
             <a:endParaRPr lang="en-US" sz="1050" dirty="0"/>
           </a:p>
@@ -16363,7 +16363,7 @@
                 <a:ea typeface="Calibri" pitchFamily="34" charset="-122"/>
                 <a:cs typeface="Calibri" pitchFamily="34" charset="-120"/>
               </a:rPr>
-              <a:t>SILVERTRUST   ·   IBERIANEX LOGISTICS S.A.   ·   DISCOVERY FINDINGS</a:t>
+              <a:t>SILVERTRUST   ·   IBERIANEX LOGISTICS S.A.   ·   PROPOSED APPROACH</a:t>
             </a:r>
             <a:endParaRPr lang="en-US" sz="1050" dirty="0"/>
           </a:p>
@@ -17449,7 +17449,7 @@
                 <a:ea typeface="Calibri" pitchFamily="34" charset="-122"/>
                 <a:cs typeface="Calibri" pitchFamily="34" charset="-120"/>
               </a:rPr>
-              <a:t>SILVERTRUST   ·   IBERIANEX LOGISTICS S.A.   ·   DISCOVERY FINDINGS</a:t>
+              <a:t>SILVERTRUST   ·   IBERIANEX LOGISTICS S.A.   ·   PROPOSED APPROACH</a:t>
             </a:r>
             <a:endParaRPr lang="en-US" sz="1050" dirty="0"/>
           </a:p>

</xml_diff>